<commit_message>
Deck: NextRare brand colours and logo on web, PDF and PPTX
Co-Authored-By: Claude Fable 5.1 <noreply@anthropic.com>
</commit_message>
<xml_diff>
--- a/docs/NextRare-Deck.pptx
+++ b/docs/NextRare-Deck.pptx
@@ -3126,7 +3126,7 @@
           </a:solidFill>
           <a:ln w="25400">
             <a:solidFill>
-              <a:srgbClr val="22D3EE"/>
+              <a:srgbClr val="DD2023"/>
             </a:solidFill>
           </a:ln>
         </p:spPr>
@@ -3230,25 +3230,49 @@
             <a:r>
               <a:rPr sz="4000" b="1">
                 <a:solidFill>
-                  <a:srgbClr val="22D3EE"/>
-                </a:solidFill>
-                <a:latin typeface="Sora"/>
-              </a:rPr>
-              <a:t>NextRare</a:t>
-            </a:r>
-          </a:p>
-        </p:txBody>
-      </p:sp>
-      <p:sp>
-        <p:nvSpPr>
-          <p:cNvPr id="5" name="TextBox 4"/>
+                  <a:srgbClr val="FF734C"/>
+                </a:solidFill>
+                <a:latin typeface="Sora"/>
+              </a:rPr>
+              <a:t/>
+            </a:r>
+          </a:p>
+        </p:txBody>
+      </p:sp>
+      <p:pic>
+        <p:nvPicPr>
+          <p:cNvPr id="5" name="Picture 4" descr="nextrare-logo.png"/>
+          <p:cNvPicPr>
+            <a:picLocks noChangeAspect="1"/>
+          </p:cNvPicPr>
+          <p:nvPr/>
+        </p:nvPicPr>
+        <p:blipFill>
+          <a:blip r:embed="rId2"/>
+          <a:stretch>
+            <a:fillRect/>
+          </a:stretch>
+        </p:blipFill>
+        <p:spPr>
+          <a:xfrm>
+            <a:off x="1005840" y="1234440"/>
+            <a:ext cx="4320540" cy="822960"/>
+          </a:xfrm>
+          <a:prstGeom prst="rect">
+            <a:avLst/>
+          </a:prstGeom>
+        </p:spPr>
+      </p:pic>
+      <p:sp>
+        <p:nvSpPr>
+          <p:cNvPr id="6" name="TextBox 5"/>
           <p:cNvSpPr txBox="1"/>
           <p:nvPr/>
         </p:nvSpPr>
         <p:spPr>
           <a:xfrm>
-            <a:off x="1005840" y="2468880"/>
-            <a:ext cx="10058400" cy="731520"/>
+            <a:off x="1005840" y="2286000"/>
+            <a:ext cx="10058400" cy="914400"/>
           </a:xfrm>
           <a:prstGeom prst="rect">
             <a:avLst/>
@@ -3267,26 +3291,35 @@
               </a:lnSpc>
             </a:pPr>
             <a:r>
-              <a:rPr sz="2800" b="0">
-                <a:solidFill>
-                  <a:srgbClr val="E4E4E7"/>
-                </a:solidFill>
-                <a:latin typeface="Sora"/>
-              </a:rPr>
-              <a:t>A trading card show at your fingertips.</a:t>
-            </a:r>
-          </a:p>
-        </p:txBody>
-      </p:sp>
-      <p:sp>
-        <p:nvSpPr>
-          <p:cNvPr id="6" name="TextBox 5"/>
+              <a:rPr sz="4000" b="1">
+                <a:solidFill>
+                  <a:srgbClr val="F4F4F5"/>
+                </a:solidFill>
+                <a:latin typeface="Sora"/>
+              </a:rPr>
+              <a:t>A trading card show </a:t>
+            </a:r>
+            <a:r>
+              <a:rPr sz="4000" b="1">
+                <a:solidFill>
+                  <a:srgbClr val="FF734C"/>
+                </a:solidFill>
+                <a:latin typeface="Sora"/>
+              </a:rPr>
+              <a:t>at your fingertips.</a:t>
+            </a:r>
+          </a:p>
+        </p:txBody>
+      </p:sp>
+      <p:sp>
+        <p:nvSpPr>
+          <p:cNvPr id="7" name="TextBox 6"/>
           <p:cNvSpPr txBox="1"/>
           <p:nvPr/>
         </p:nvSpPr>
         <p:spPr>
           <a:xfrm>
-            <a:off x="1005840" y="3291840"/>
+            <a:off x="1005840" y="3429000"/>
             <a:ext cx="10058400" cy="548640"/>
           </a:xfrm>
           <a:prstGeom prst="rect">
@@ -3319,13 +3352,13 @@
       </p:sp>
       <p:sp>
         <p:nvSpPr>
-          <p:cNvPr id="7" name="TextBox 6"/>
+          <p:cNvPr id="8" name="TextBox 7"/>
           <p:cNvSpPr txBox="1"/>
           <p:nvPr/>
         </p:nvSpPr>
         <p:spPr>
           <a:xfrm>
-            <a:off x="1005840" y="4114800"/>
+            <a:off x="1005840" y="4206240"/>
             <a:ext cx="10058400" cy="457200"/>
           </a:xfrm>
           <a:prstGeom prst="rect">
@@ -3358,13 +3391,13 @@
       </p:sp>
       <p:sp>
         <p:nvSpPr>
-          <p:cNvPr id="8" name="TextBox 7"/>
+          <p:cNvPr id="9" name="TextBox 8"/>
           <p:cNvSpPr txBox="1"/>
           <p:nvPr/>
         </p:nvSpPr>
         <p:spPr>
           <a:xfrm>
-            <a:off x="1005840" y="4572000"/>
+            <a:off x="1005840" y="4663440"/>
             <a:ext cx="10058400" cy="457200"/>
           </a:xfrm>
           <a:prstGeom prst="rect">
@@ -3386,7 +3419,7 @@
             <a:r>
               <a:rPr sz="1400" b="0">
                 <a:solidFill>
-                  <a:srgbClr val="22D3EE"/>
+                  <a:srgbClr val="FF734C"/>
                 </a:solidFill>
                 <a:latin typeface="Sora"/>
               </a:rPr>
@@ -3397,7 +3430,7 @@
       </p:sp>
       <p:sp>
         <p:nvSpPr>
-          <p:cNvPr id="9" name="TextBox 8"/>
+          <p:cNvPr id="10" name="TextBox 9"/>
           <p:cNvSpPr txBox="1"/>
           <p:nvPr/>
         </p:nvSpPr>
@@ -3436,7 +3469,7 @@
       </p:sp>
       <p:sp>
         <p:nvSpPr>
-          <p:cNvPr id="10" name="TextBox 9"/>
+          <p:cNvPr id="11" name="TextBox 10"/>
           <p:cNvSpPr txBox="1"/>
           <p:nvPr/>
         </p:nvSpPr>
@@ -3520,7 +3553,7 @@
           </a:solidFill>
           <a:ln w="25400">
             <a:solidFill>
-              <a:srgbClr val="22D3EE"/>
+              <a:srgbClr val="DD2023"/>
             </a:solidFill>
           </a:ln>
         </p:spPr>
@@ -3546,9 +3579,33 @@
           </a:p>
         </p:txBody>
       </p:sp>
-      <p:sp>
-        <p:nvSpPr>
-          <p:cNvPr id="3" name="TextBox 2"/>
+      <p:pic>
+        <p:nvPicPr>
+          <p:cNvPr id="3" name="Picture 2" descr="nextrare-logo.png"/>
+          <p:cNvPicPr>
+            <a:picLocks noChangeAspect="1"/>
+          </p:cNvPicPr>
+          <p:nvPr/>
+        </p:nvPicPr>
+        <p:blipFill>
+          <a:blip r:embed="rId2"/>
+          <a:stretch>
+            <a:fillRect/>
+          </a:stretch>
+        </p:blipFill>
+        <p:spPr>
+          <a:xfrm>
+            <a:off x="9418320" y="804672"/>
+            <a:ext cx="1728216" cy="329184"/>
+          </a:xfrm>
+          <a:prstGeom prst="rect">
+            <a:avLst/>
+          </a:prstGeom>
+        </p:spPr>
+      </p:pic>
+      <p:sp>
+        <p:nvSpPr>
+          <p:cNvPr id="4" name="TextBox 3"/>
           <p:cNvSpPr txBox="1"/>
           <p:nvPr/>
         </p:nvSpPr>
@@ -3587,7 +3644,7 @@
       </p:sp>
       <p:sp>
         <p:nvSpPr>
-          <p:cNvPr id="4" name="TextBox 3"/>
+          <p:cNvPr id="5" name="TextBox 4"/>
           <p:cNvSpPr txBox="1"/>
           <p:nvPr/>
         </p:nvSpPr>
@@ -3624,7 +3681,7 @@
             <a:r>
               <a:rPr sz="4000" b="1">
                 <a:solidFill>
-                  <a:srgbClr val="22D3EE"/>
+                  <a:srgbClr val="FF734C"/>
                 </a:solidFill>
                 <a:latin typeface="Sora"/>
               </a:rPr>
@@ -3635,7 +3692,7 @@
       </p:sp>
       <p:sp>
         <p:nvSpPr>
-          <p:cNvPr id="5" name="Rounded Rectangle 4"/>
+          <p:cNvPr id="6" name="Rounded Rectangle 5"/>
           <p:cNvSpPr/>
           <p:nvPr/>
         </p:nvSpPr>
@@ -3682,7 +3739,7 @@
       </p:sp>
       <p:sp>
         <p:nvSpPr>
-          <p:cNvPr id="6" name="TextBox 5"/>
+          <p:cNvPr id="7" name="TextBox 6"/>
           <p:cNvSpPr txBox="1"/>
           <p:nvPr/>
         </p:nvSpPr>
@@ -3721,7 +3778,7 @@
       </p:sp>
       <p:sp>
         <p:nvSpPr>
-          <p:cNvPr id="7" name="TextBox 6"/>
+          <p:cNvPr id="8" name="TextBox 7"/>
           <p:cNvSpPr txBox="1"/>
           <p:nvPr/>
         </p:nvSpPr>
@@ -3760,7 +3817,7 @@
       </p:sp>
       <p:sp>
         <p:nvSpPr>
-          <p:cNvPr id="8" name="Rounded Rectangle 7"/>
+          <p:cNvPr id="9" name="Rounded Rectangle 8"/>
           <p:cNvSpPr/>
           <p:nvPr/>
         </p:nvSpPr>
@@ -3807,7 +3864,7 @@
       </p:sp>
       <p:sp>
         <p:nvSpPr>
-          <p:cNvPr id="9" name="TextBox 8"/>
+          <p:cNvPr id="10" name="TextBox 9"/>
           <p:cNvSpPr txBox="1"/>
           <p:nvPr/>
         </p:nvSpPr>
@@ -3846,7 +3903,7 @@
       </p:sp>
       <p:sp>
         <p:nvSpPr>
-          <p:cNvPr id="10" name="TextBox 9"/>
+          <p:cNvPr id="11" name="TextBox 10"/>
           <p:cNvSpPr txBox="1"/>
           <p:nvPr/>
         </p:nvSpPr>
@@ -3885,7 +3942,7 @@
       </p:sp>
       <p:sp>
         <p:nvSpPr>
-          <p:cNvPr id="11" name="Rounded Rectangle 10"/>
+          <p:cNvPr id="12" name="Rounded Rectangle 11"/>
           <p:cNvSpPr/>
           <p:nvPr/>
         </p:nvSpPr>
@@ -3932,7 +3989,7 @@
       </p:sp>
       <p:sp>
         <p:nvSpPr>
-          <p:cNvPr id="12" name="TextBox 11"/>
+          <p:cNvPr id="13" name="TextBox 12"/>
           <p:cNvSpPr txBox="1"/>
           <p:nvPr/>
         </p:nvSpPr>
@@ -3971,7 +4028,7 @@
       </p:sp>
       <p:sp>
         <p:nvSpPr>
-          <p:cNvPr id="13" name="TextBox 12"/>
+          <p:cNvPr id="14" name="TextBox 13"/>
           <p:cNvSpPr txBox="1"/>
           <p:nvPr/>
         </p:nvSpPr>
@@ -4010,7 +4067,7 @@
       </p:sp>
       <p:sp>
         <p:nvSpPr>
-          <p:cNvPr id="14" name="TextBox 13"/>
+          <p:cNvPr id="15" name="TextBox 14"/>
           <p:cNvSpPr txBox="1"/>
           <p:nvPr/>
         </p:nvSpPr>
@@ -4167,7 +4224,7 @@
             <a:r>
               <a:rPr sz="1600" b="0">
                 <a:solidFill>
-                  <a:srgbClr val="22D3EE"/>
+                  <a:srgbClr val="FF734C"/>
                 </a:solidFill>
                 <a:latin typeface="Sora"/>
               </a:rPr>
@@ -4178,7 +4235,7 @@
       </p:sp>
       <p:sp>
         <p:nvSpPr>
-          <p:cNvPr id="15" name="TextBox 14"/>
+          <p:cNvPr id="16" name="TextBox 15"/>
           <p:cNvSpPr txBox="1"/>
           <p:nvPr/>
         </p:nvSpPr>
@@ -4217,7 +4274,7 @@
       </p:sp>
       <p:sp>
         <p:nvSpPr>
-          <p:cNvPr id="16" name="TextBox 15"/>
+          <p:cNvPr id="17" name="TextBox 16"/>
           <p:cNvSpPr txBox="1"/>
           <p:nvPr/>
         </p:nvSpPr>
@@ -4301,7 +4358,7 @@
           </a:solidFill>
           <a:ln w="25400">
             <a:solidFill>
-              <a:srgbClr val="22D3EE"/>
+              <a:srgbClr val="DD2023"/>
             </a:solidFill>
           </a:ln>
         </p:spPr>
@@ -4327,9 +4384,33 @@
           </a:p>
         </p:txBody>
       </p:sp>
-      <p:sp>
-        <p:nvSpPr>
-          <p:cNvPr id="3" name="TextBox 2"/>
+      <p:pic>
+        <p:nvPicPr>
+          <p:cNvPr id="3" name="Picture 2" descr="nextrare-logo.png"/>
+          <p:cNvPicPr>
+            <a:picLocks noChangeAspect="1"/>
+          </p:cNvPicPr>
+          <p:nvPr/>
+        </p:nvPicPr>
+        <p:blipFill>
+          <a:blip r:embed="rId2"/>
+          <a:stretch>
+            <a:fillRect/>
+          </a:stretch>
+        </p:blipFill>
+        <p:spPr>
+          <a:xfrm>
+            <a:off x="9418320" y="804672"/>
+            <a:ext cx="1728216" cy="329184"/>
+          </a:xfrm>
+          <a:prstGeom prst="rect">
+            <a:avLst/>
+          </a:prstGeom>
+        </p:spPr>
+      </p:pic>
+      <p:sp>
+        <p:nvSpPr>
+          <p:cNvPr id="4" name="TextBox 3"/>
           <p:cNvSpPr txBox="1"/>
           <p:nvPr/>
         </p:nvSpPr>
@@ -4368,7 +4449,7 @@
       </p:sp>
       <p:sp>
         <p:nvSpPr>
-          <p:cNvPr id="4" name="TextBox 3"/>
+          <p:cNvPr id="5" name="TextBox 4"/>
           <p:cNvSpPr txBox="1"/>
           <p:nvPr/>
         </p:nvSpPr>
@@ -4405,7 +4486,7 @@
             <a:r>
               <a:rPr sz="4000" b="1">
                 <a:solidFill>
-                  <a:srgbClr val="22D3EE"/>
+                  <a:srgbClr val="FF734C"/>
                 </a:solidFill>
                 <a:latin typeface="Sora"/>
               </a:rPr>
@@ -4416,7 +4497,7 @@
       </p:sp>
       <p:sp>
         <p:nvSpPr>
-          <p:cNvPr id="5" name="TextBox 4"/>
+          <p:cNvPr id="6" name="TextBox 5"/>
           <p:cNvSpPr txBox="1"/>
           <p:nvPr/>
         </p:nvSpPr>
@@ -4520,7 +4601,7 @@
       </p:sp>
       <p:sp>
         <p:nvSpPr>
-          <p:cNvPr id="6" name="TextBox 5"/>
+          <p:cNvPr id="7" name="TextBox 6"/>
           <p:cNvSpPr txBox="1"/>
           <p:nvPr/>
         </p:nvSpPr>
@@ -4559,7 +4640,7 @@
       </p:sp>
       <p:sp>
         <p:nvSpPr>
-          <p:cNvPr id="7" name="TextBox 6"/>
+          <p:cNvPr id="8" name="TextBox 7"/>
           <p:cNvSpPr txBox="1"/>
           <p:nvPr/>
         </p:nvSpPr>
@@ -4643,7 +4724,7 @@
           </a:solidFill>
           <a:ln w="25400">
             <a:solidFill>
-              <a:srgbClr val="22D3EE"/>
+              <a:srgbClr val="DD2023"/>
             </a:solidFill>
           </a:ln>
         </p:spPr>
@@ -4669,9 +4750,33 @@
           </a:p>
         </p:txBody>
       </p:sp>
-      <p:sp>
-        <p:nvSpPr>
-          <p:cNvPr id="3" name="TextBox 2"/>
+      <p:pic>
+        <p:nvPicPr>
+          <p:cNvPr id="3" name="Picture 2" descr="nextrare-logo.png"/>
+          <p:cNvPicPr>
+            <a:picLocks noChangeAspect="1"/>
+          </p:cNvPicPr>
+          <p:nvPr/>
+        </p:nvPicPr>
+        <p:blipFill>
+          <a:blip r:embed="rId2"/>
+          <a:stretch>
+            <a:fillRect/>
+          </a:stretch>
+        </p:blipFill>
+        <p:spPr>
+          <a:xfrm>
+            <a:off x="9418320" y="804672"/>
+            <a:ext cx="1728216" cy="329184"/>
+          </a:xfrm>
+          <a:prstGeom prst="rect">
+            <a:avLst/>
+          </a:prstGeom>
+        </p:spPr>
+      </p:pic>
+      <p:sp>
+        <p:nvSpPr>
+          <p:cNvPr id="4" name="TextBox 3"/>
           <p:cNvSpPr txBox="1"/>
           <p:nvPr/>
         </p:nvSpPr>
@@ -4710,7 +4815,7 @@
       </p:sp>
       <p:sp>
         <p:nvSpPr>
-          <p:cNvPr id="4" name="TextBox 3"/>
+          <p:cNvPr id="5" name="TextBox 4"/>
           <p:cNvSpPr txBox="1"/>
           <p:nvPr/>
         </p:nvSpPr>
@@ -4747,7 +4852,7 @@
             <a:r>
               <a:rPr sz="4000" b="1">
                 <a:solidFill>
-                  <a:srgbClr val="22D3EE"/>
+                  <a:srgbClr val="FF734C"/>
                 </a:solidFill>
                 <a:latin typeface="Sora"/>
               </a:rPr>
@@ -4758,7 +4863,7 @@
       </p:sp>
       <p:sp>
         <p:nvSpPr>
-          <p:cNvPr id="5" name="TextBox 4"/>
+          <p:cNvPr id="6" name="TextBox 5"/>
           <p:cNvSpPr txBox="1"/>
           <p:nvPr/>
         </p:nvSpPr>
@@ -4890,7 +4995,7 @@
       </p:sp>
       <p:sp>
         <p:nvSpPr>
-          <p:cNvPr id="6" name="TextBox 5"/>
+          <p:cNvPr id="7" name="TextBox 6"/>
           <p:cNvSpPr txBox="1"/>
           <p:nvPr/>
         </p:nvSpPr>
@@ -4929,7 +5034,7 @@
       </p:sp>
       <p:sp>
         <p:nvSpPr>
-          <p:cNvPr id="7" name="TextBox 6"/>
+          <p:cNvPr id="8" name="TextBox 7"/>
           <p:cNvSpPr txBox="1"/>
           <p:nvPr/>
         </p:nvSpPr>
@@ -5013,7 +5118,7 @@
           </a:solidFill>
           <a:ln w="25400">
             <a:solidFill>
-              <a:srgbClr val="22D3EE"/>
+              <a:srgbClr val="DD2023"/>
             </a:solidFill>
           </a:ln>
         </p:spPr>
@@ -5039,9 +5144,33 @@
           </a:p>
         </p:txBody>
       </p:sp>
-      <p:sp>
-        <p:nvSpPr>
-          <p:cNvPr id="3" name="TextBox 2"/>
+      <p:pic>
+        <p:nvPicPr>
+          <p:cNvPr id="3" name="Picture 2" descr="nextrare-logo.png"/>
+          <p:cNvPicPr>
+            <a:picLocks noChangeAspect="1"/>
+          </p:cNvPicPr>
+          <p:nvPr/>
+        </p:nvPicPr>
+        <p:blipFill>
+          <a:blip r:embed="rId2"/>
+          <a:stretch>
+            <a:fillRect/>
+          </a:stretch>
+        </p:blipFill>
+        <p:spPr>
+          <a:xfrm>
+            <a:off x="9418320" y="804672"/>
+            <a:ext cx="1728216" cy="329184"/>
+          </a:xfrm>
+          <a:prstGeom prst="rect">
+            <a:avLst/>
+          </a:prstGeom>
+        </p:spPr>
+      </p:pic>
+      <p:sp>
+        <p:nvSpPr>
+          <p:cNvPr id="4" name="TextBox 3"/>
           <p:cNvSpPr txBox="1"/>
           <p:nvPr/>
         </p:nvSpPr>
@@ -5080,7 +5209,7 @@
       </p:sp>
       <p:sp>
         <p:nvSpPr>
-          <p:cNvPr id="4" name="TextBox 3"/>
+          <p:cNvPr id="5" name="TextBox 4"/>
           <p:cNvSpPr txBox="1"/>
           <p:nvPr/>
         </p:nvSpPr>
@@ -5117,7 +5246,7 @@
             <a:r>
               <a:rPr sz="4000" b="1">
                 <a:solidFill>
-                  <a:srgbClr val="22D3EE"/>
+                  <a:srgbClr val="FF734C"/>
                 </a:solidFill>
                 <a:latin typeface="Sora"/>
               </a:rPr>
@@ -5128,7 +5257,7 @@
       </p:sp>
       <p:sp>
         <p:nvSpPr>
-          <p:cNvPr id="5" name="TextBox 4"/>
+          <p:cNvPr id="6" name="TextBox 5"/>
           <p:cNvSpPr txBox="1"/>
           <p:nvPr/>
         </p:nvSpPr>
@@ -5156,7 +5285,7 @@
             <a:r>
               <a:rPr sz="1900" b="1">
                 <a:solidFill>
-                  <a:srgbClr val="22D3EE"/>
+                  <a:srgbClr val="FF734C"/>
                 </a:solidFill>
                 <a:latin typeface="Sora"/>
               </a:rPr>
@@ -5184,7 +5313,7 @@
             <a:r>
               <a:rPr sz="1900" b="1">
                 <a:solidFill>
-                  <a:srgbClr val="22D3EE"/>
+                  <a:srgbClr val="FF734C"/>
                 </a:solidFill>
                 <a:latin typeface="Sora"/>
               </a:rPr>
@@ -5212,7 +5341,7 @@
             <a:r>
               <a:rPr sz="1900" b="1">
                 <a:solidFill>
-                  <a:srgbClr val="22D3EE"/>
+                  <a:srgbClr val="FF734C"/>
                 </a:solidFill>
                 <a:latin typeface="Sora"/>
               </a:rPr>
@@ -5240,7 +5369,7 @@
             <a:r>
               <a:rPr sz="1900" b="1">
                 <a:solidFill>
-                  <a:srgbClr val="22D3EE"/>
+                  <a:srgbClr val="FF734C"/>
                 </a:solidFill>
                 <a:latin typeface="Sora"/>
               </a:rPr>
@@ -5268,7 +5397,7 @@
             <a:r>
               <a:rPr sz="1900" b="1">
                 <a:solidFill>
-                  <a:srgbClr val="22D3EE"/>
+                  <a:srgbClr val="FF734C"/>
                 </a:solidFill>
                 <a:latin typeface="Sora"/>
               </a:rPr>
@@ -5288,7 +5417,7 @@
       </p:sp>
       <p:sp>
         <p:nvSpPr>
-          <p:cNvPr id="6" name="TextBox 5"/>
+          <p:cNvPr id="7" name="TextBox 6"/>
           <p:cNvSpPr txBox="1"/>
           <p:nvPr/>
         </p:nvSpPr>
@@ -5316,7 +5445,7 @@
             <a:r>
               <a:rPr sz="1400" b="0">
                 <a:solidFill>
-                  <a:srgbClr val="22D3EE"/>
+                  <a:srgbClr val="FF734C"/>
                 </a:solidFill>
                 <a:latin typeface="Sora"/>
               </a:rPr>
@@ -5327,7 +5456,7 @@
       </p:sp>
       <p:sp>
         <p:nvSpPr>
-          <p:cNvPr id="7" name="TextBox 6"/>
+          <p:cNvPr id="8" name="TextBox 7"/>
           <p:cNvSpPr txBox="1"/>
           <p:nvPr/>
         </p:nvSpPr>
@@ -5366,7 +5495,7 @@
       </p:sp>
       <p:sp>
         <p:nvSpPr>
-          <p:cNvPr id="8" name="TextBox 7"/>
+          <p:cNvPr id="9" name="TextBox 8"/>
           <p:cNvSpPr txBox="1"/>
           <p:nvPr/>
         </p:nvSpPr>
@@ -5450,7 +5579,7 @@
           </a:solidFill>
           <a:ln w="25400">
             <a:solidFill>
-              <a:srgbClr val="22D3EE"/>
+              <a:srgbClr val="DD2023"/>
             </a:solidFill>
           </a:ln>
         </p:spPr>
@@ -5476,9 +5605,33 @@
           </a:p>
         </p:txBody>
       </p:sp>
-      <p:sp>
-        <p:nvSpPr>
-          <p:cNvPr id="3" name="TextBox 2"/>
+      <p:pic>
+        <p:nvPicPr>
+          <p:cNvPr id="3" name="Picture 2" descr="nextrare-logo.png"/>
+          <p:cNvPicPr>
+            <a:picLocks noChangeAspect="1"/>
+          </p:cNvPicPr>
+          <p:nvPr/>
+        </p:nvPicPr>
+        <p:blipFill>
+          <a:blip r:embed="rId2"/>
+          <a:stretch>
+            <a:fillRect/>
+          </a:stretch>
+        </p:blipFill>
+        <p:spPr>
+          <a:xfrm>
+            <a:off x="9418320" y="804672"/>
+            <a:ext cx="1728216" cy="329184"/>
+          </a:xfrm>
+          <a:prstGeom prst="rect">
+            <a:avLst/>
+          </a:prstGeom>
+        </p:spPr>
+      </p:pic>
+      <p:sp>
+        <p:nvSpPr>
+          <p:cNvPr id="4" name="TextBox 3"/>
           <p:cNvSpPr txBox="1"/>
           <p:nvPr/>
         </p:nvSpPr>
@@ -5517,7 +5670,7 @@
       </p:sp>
       <p:sp>
         <p:nvSpPr>
-          <p:cNvPr id="4" name="TextBox 3"/>
+          <p:cNvPr id="5" name="TextBox 4"/>
           <p:cNvSpPr txBox="1"/>
           <p:nvPr/>
         </p:nvSpPr>
@@ -5554,7 +5707,7 @@
             <a:r>
               <a:rPr sz="4000" b="1">
                 <a:solidFill>
-                  <a:srgbClr val="22D3EE"/>
+                  <a:srgbClr val="FF734C"/>
                 </a:solidFill>
                 <a:latin typeface="Sora"/>
               </a:rPr>
@@ -5565,7 +5718,7 @@
       </p:sp>
       <p:sp>
         <p:nvSpPr>
-          <p:cNvPr id="5" name="TextBox 4"/>
+          <p:cNvPr id="6" name="TextBox 5"/>
           <p:cNvSpPr txBox="1"/>
           <p:nvPr/>
         </p:nvSpPr>
@@ -5604,7 +5757,7 @@
       </p:sp>
       <p:sp>
         <p:nvSpPr>
-          <p:cNvPr id="6" name="Rounded Rectangle 5"/>
+          <p:cNvPr id="7" name="Rounded Rectangle 6"/>
           <p:cNvSpPr/>
           <p:nvPr/>
         </p:nvSpPr>
@@ -5651,7 +5804,7 @@
       </p:sp>
       <p:sp>
         <p:nvSpPr>
-          <p:cNvPr id="7" name="TextBox 6"/>
+          <p:cNvPr id="8" name="TextBox 7"/>
           <p:cNvSpPr txBox="1"/>
           <p:nvPr/>
         </p:nvSpPr>
@@ -5690,7 +5843,7 @@
       </p:sp>
       <p:sp>
         <p:nvSpPr>
-          <p:cNvPr id="8" name="TextBox 7"/>
+          <p:cNvPr id="9" name="TextBox 8"/>
           <p:cNvSpPr txBox="1"/>
           <p:nvPr/>
         </p:nvSpPr>
@@ -5729,7 +5882,7 @@
       </p:sp>
       <p:sp>
         <p:nvSpPr>
-          <p:cNvPr id="9" name="Rounded Rectangle 8"/>
+          <p:cNvPr id="10" name="Rounded Rectangle 9"/>
           <p:cNvSpPr/>
           <p:nvPr/>
         </p:nvSpPr>
@@ -5776,7 +5929,7 @@
       </p:sp>
       <p:sp>
         <p:nvSpPr>
-          <p:cNvPr id="10" name="TextBox 9"/>
+          <p:cNvPr id="11" name="TextBox 10"/>
           <p:cNvSpPr txBox="1"/>
           <p:nvPr/>
         </p:nvSpPr>
@@ -5815,7 +5968,7 @@
       </p:sp>
       <p:sp>
         <p:nvSpPr>
-          <p:cNvPr id="11" name="TextBox 10"/>
+          <p:cNvPr id="12" name="TextBox 11"/>
           <p:cNvSpPr txBox="1"/>
           <p:nvPr/>
         </p:nvSpPr>
@@ -5854,7 +6007,7 @@
       </p:sp>
       <p:sp>
         <p:nvSpPr>
-          <p:cNvPr id="12" name="Rounded Rectangle 11"/>
+          <p:cNvPr id="13" name="Rounded Rectangle 12"/>
           <p:cNvSpPr/>
           <p:nvPr/>
         </p:nvSpPr>
@@ -5901,7 +6054,7 @@
       </p:sp>
       <p:sp>
         <p:nvSpPr>
-          <p:cNvPr id="13" name="TextBox 12"/>
+          <p:cNvPr id="14" name="TextBox 13"/>
           <p:cNvSpPr txBox="1"/>
           <p:nvPr/>
         </p:nvSpPr>
@@ -5940,7 +6093,7 @@
       </p:sp>
       <p:sp>
         <p:nvSpPr>
-          <p:cNvPr id="14" name="TextBox 13"/>
+          <p:cNvPr id="15" name="TextBox 14"/>
           <p:cNvSpPr txBox="1"/>
           <p:nvPr/>
         </p:nvSpPr>
@@ -5979,7 +6132,7 @@
       </p:sp>
       <p:sp>
         <p:nvSpPr>
-          <p:cNvPr id="15" name="Rounded Rectangle 14"/>
+          <p:cNvPr id="16" name="Rounded Rectangle 15"/>
           <p:cNvSpPr/>
           <p:nvPr/>
         </p:nvSpPr>
@@ -6026,7 +6179,7 @@
       </p:sp>
       <p:sp>
         <p:nvSpPr>
-          <p:cNvPr id="16" name="TextBox 15"/>
+          <p:cNvPr id="17" name="TextBox 16"/>
           <p:cNvSpPr txBox="1"/>
           <p:nvPr/>
         </p:nvSpPr>
@@ -6065,7 +6218,7 @@
       </p:sp>
       <p:sp>
         <p:nvSpPr>
-          <p:cNvPr id="17" name="TextBox 16"/>
+          <p:cNvPr id="18" name="TextBox 17"/>
           <p:cNvSpPr txBox="1"/>
           <p:nvPr/>
         </p:nvSpPr>
@@ -6104,7 +6257,7 @@
       </p:sp>
       <p:sp>
         <p:nvSpPr>
-          <p:cNvPr id="18" name="Rounded Rectangle 17"/>
+          <p:cNvPr id="19" name="Rounded Rectangle 18"/>
           <p:cNvSpPr/>
           <p:nvPr/>
         </p:nvSpPr>
@@ -6151,7 +6304,7 @@
       </p:sp>
       <p:sp>
         <p:nvSpPr>
-          <p:cNvPr id="19" name="TextBox 18"/>
+          <p:cNvPr id="20" name="TextBox 19"/>
           <p:cNvSpPr txBox="1"/>
           <p:nvPr/>
         </p:nvSpPr>
@@ -6190,7 +6343,7 @@
       </p:sp>
       <p:sp>
         <p:nvSpPr>
-          <p:cNvPr id="20" name="TextBox 19"/>
+          <p:cNvPr id="21" name="TextBox 20"/>
           <p:cNvSpPr txBox="1"/>
           <p:nvPr/>
         </p:nvSpPr>
@@ -6229,7 +6382,7 @@
       </p:sp>
       <p:sp>
         <p:nvSpPr>
-          <p:cNvPr id="21" name="Rounded Rectangle 20"/>
+          <p:cNvPr id="22" name="Rounded Rectangle 21"/>
           <p:cNvSpPr/>
           <p:nvPr/>
         </p:nvSpPr>
@@ -6276,7 +6429,7 @@
       </p:sp>
       <p:sp>
         <p:nvSpPr>
-          <p:cNvPr id="22" name="TextBox 21"/>
+          <p:cNvPr id="23" name="TextBox 22"/>
           <p:cNvSpPr txBox="1"/>
           <p:nvPr/>
         </p:nvSpPr>
@@ -6315,7 +6468,7 @@
       </p:sp>
       <p:sp>
         <p:nvSpPr>
-          <p:cNvPr id="23" name="TextBox 22"/>
+          <p:cNvPr id="24" name="TextBox 23"/>
           <p:cNvSpPr txBox="1"/>
           <p:nvPr/>
         </p:nvSpPr>
@@ -6354,7 +6507,7 @@
       </p:sp>
       <p:sp>
         <p:nvSpPr>
-          <p:cNvPr id="24" name="TextBox 23"/>
+          <p:cNvPr id="25" name="TextBox 24"/>
           <p:cNvSpPr txBox="1"/>
           <p:nvPr/>
         </p:nvSpPr>
@@ -6538,7 +6691,7 @@
       </p:sp>
       <p:sp>
         <p:nvSpPr>
-          <p:cNvPr id="25" name="TextBox 24"/>
+          <p:cNvPr id="26" name="TextBox 25"/>
           <p:cNvSpPr txBox="1"/>
           <p:nvPr/>
         </p:nvSpPr>
@@ -6577,7 +6730,7 @@
       </p:sp>
       <p:sp>
         <p:nvSpPr>
-          <p:cNvPr id="26" name="TextBox 25"/>
+          <p:cNvPr id="27" name="TextBox 26"/>
           <p:cNvSpPr txBox="1"/>
           <p:nvPr/>
         </p:nvSpPr>
@@ -6661,7 +6814,7 @@
           </a:solidFill>
           <a:ln w="25400">
             <a:solidFill>
-              <a:srgbClr val="22D3EE"/>
+              <a:srgbClr val="DD2023"/>
             </a:solidFill>
           </a:ln>
         </p:spPr>
@@ -6687,9 +6840,33 @@
           </a:p>
         </p:txBody>
       </p:sp>
-      <p:sp>
-        <p:nvSpPr>
-          <p:cNvPr id="3" name="TextBox 2"/>
+      <p:pic>
+        <p:nvPicPr>
+          <p:cNvPr id="3" name="Picture 2" descr="nextrare-logo.png"/>
+          <p:cNvPicPr>
+            <a:picLocks noChangeAspect="1"/>
+          </p:cNvPicPr>
+          <p:nvPr/>
+        </p:nvPicPr>
+        <p:blipFill>
+          <a:blip r:embed="rId2"/>
+          <a:stretch>
+            <a:fillRect/>
+          </a:stretch>
+        </p:blipFill>
+        <p:spPr>
+          <a:xfrm>
+            <a:off x="9418320" y="804672"/>
+            <a:ext cx="1728216" cy="329184"/>
+          </a:xfrm>
+          <a:prstGeom prst="rect">
+            <a:avLst/>
+          </a:prstGeom>
+        </p:spPr>
+      </p:pic>
+      <p:sp>
+        <p:nvSpPr>
+          <p:cNvPr id="4" name="TextBox 3"/>
           <p:cNvSpPr txBox="1"/>
           <p:nvPr/>
         </p:nvSpPr>
@@ -6728,7 +6905,7 @@
       </p:sp>
       <p:sp>
         <p:nvSpPr>
-          <p:cNvPr id="4" name="TextBox 3"/>
+          <p:cNvPr id="5" name="TextBox 4"/>
           <p:cNvSpPr txBox="1"/>
           <p:nvPr/>
         </p:nvSpPr>
@@ -6765,7 +6942,7 @@
             <a:r>
               <a:rPr sz="4000" b="1">
                 <a:solidFill>
-                  <a:srgbClr val="22D3EE"/>
+                  <a:srgbClr val="FF734C"/>
                 </a:solidFill>
                 <a:latin typeface="Sora"/>
               </a:rPr>
@@ -6776,7 +6953,7 @@
       </p:sp>
       <p:sp>
         <p:nvSpPr>
-          <p:cNvPr id="5" name="TextBox 4"/>
+          <p:cNvPr id="6" name="TextBox 5"/>
           <p:cNvSpPr txBox="1"/>
           <p:nvPr/>
         </p:nvSpPr>
@@ -6880,7 +7057,7 @@
       </p:sp>
       <p:sp>
         <p:nvSpPr>
-          <p:cNvPr id="6" name="TextBox 5"/>
+          <p:cNvPr id="7" name="TextBox 6"/>
           <p:cNvSpPr txBox="1"/>
           <p:nvPr/>
         </p:nvSpPr>
@@ -6919,7 +7096,7 @@
       </p:sp>
       <p:sp>
         <p:nvSpPr>
-          <p:cNvPr id="7" name="TextBox 6"/>
+          <p:cNvPr id="8" name="TextBox 7"/>
           <p:cNvSpPr txBox="1"/>
           <p:nvPr/>
         </p:nvSpPr>
@@ -7003,7 +7180,7 @@
           </a:solidFill>
           <a:ln w="25400">
             <a:solidFill>
-              <a:srgbClr val="22D3EE"/>
+              <a:srgbClr val="DD2023"/>
             </a:solidFill>
           </a:ln>
         </p:spPr>
@@ -7029,9 +7206,33 @@
           </a:p>
         </p:txBody>
       </p:sp>
-      <p:sp>
-        <p:nvSpPr>
-          <p:cNvPr id="3" name="TextBox 2"/>
+      <p:pic>
+        <p:nvPicPr>
+          <p:cNvPr id="3" name="Picture 2" descr="nextrare-logo.png"/>
+          <p:cNvPicPr>
+            <a:picLocks noChangeAspect="1"/>
+          </p:cNvPicPr>
+          <p:nvPr/>
+        </p:nvPicPr>
+        <p:blipFill>
+          <a:blip r:embed="rId2"/>
+          <a:stretch>
+            <a:fillRect/>
+          </a:stretch>
+        </p:blipFill>
+        <p:spPr>
+          <a:xfrm>
+            <a:off x="9418320" y="804672"/>
+            <a:ext cx="1728216" cy="329184"/>
+          </a:xfrm>
+          <a:prstGeom prst="rect">
+            <a:avLst/>
+          </a:prstGeom>
+        </p:spPr>
+      </p:pic>
+      <p:sp>
+        <p:nvSpPr>
+          <p:cNvPr id="4" name="TextBox 3"/>
           <p:cNvSpPr txBox="1"/>
           <p:nvPr/>
         </p:nvSpPr>
@@ -7070,7 +7271,7 @@
       </p:sp>
       <p:sp>
         <p:nvSpPr>
-          <p:cNvPr id="4" name="TextBox 3"/>
+          <p:cNvPr id="5" name="TextBox 4"/>
           <p:cNvSpPr txBox="1"/>
           <p:nvPr/>
         </p:nvSpPr>
@@ -7107,7 +7308,7 @@
             <a:r>
               <a:rPr sz="4000" b="1">
                 <a:solidFill>
-                  <a:srgbClr val="22D3EE"/>
+                  <a:srgbClr val="FF734C"/>
                 </a:solidFill>
                 <a:latin typeface="Sora"/>
               </a:rPr>
@@ -7118,7 +7319,7 @@
       </p:sp>
       <p:sp>
         <p:nvSpPr>
-          <p:cNvPr id="5" name="TextBox 4"/>
+          <p:cNvPr id="6" name="TextBox 5"/>
           <p:cNvSpPr txBox="1"/>
           <p:nvPr/>
         </p:nvSpPr>
@@ -7249,7 +7450,7 @@
       </p:sp>
       <p:sp>
         <p:nvSpPr>
-          <p:cNvPr id="6" name="TextBox 5"/>
+          <p:cNvPr id="7" name="TextBox 6"/>
           <p:cNvSpPr txBox="1"/>
           <p:nvPr/>
         </p:nvSpPr>
@@ -7288,7 +7489,7 @@
       </p:sp>
       <p:sp>
         <p:nvSpPr>
-          <p:cNvPr id="7" name="TextBox 6"/>
+          <p:cNvPr id="8" name="TextBox 7"/>
           <p:cNvSpPr txBox="1"/>
           <p:nvPr/>
         </p:nvSpPr>
@@ -7372,7 +7573,7 @@
           </a:solidFill>
           <a:ln w="25400">
             <a:solidFill>
-              <a:srgbClr val="22D3EE"/>
+              <a:srgbClr val="DD2023"/>
             </a:solidFill>
           </a:ln>
         </p:spPr>
@@ -7398,9 +7599,33 @@
           </a:p>
         </p:txBody>
       </p:sp>
-      <p:sp>
-        <p:nvSpPr>
-          <p:cNvPr id="3" name="TextBox 2"/>
+      <p:pic>
+        <p:nvPicPr>
+          <p:cNvPr id="3" name="Picture 2" descr="nextrare-logo.png"/>
+          <p:cNvPicPr>
+            <a:picLocks noChangeAspect="1"/>
+          </p:cNvPicPr>
+          <p:nvPr/>
+        </p:nvPicPr>
+        <p:blipFill>
+          <a:blip r:embed="rId2"/>
+          <a:stretch>
+            <a:fillRect/>
+          </a:stretch>
+        </p:blipFill>
+        <p:spPr>
+          <a:xfrm>
+            <a:off x="9418320" y="804672"/>
+            <a:ext cx="1728216" cy="329184"/>
+          </a:xfrm>
+          <a:prstGeom prst="rect">
+            <a:avLst/>
+          </a:prstGeom>
+        </p:spPr>
+      </p:pic>
+      <p:sp>
+        <p:nvSpPr>
+          <p:cNvPr id="4" name="TextBox 3"/>
           <p:cNvSpPr txBox="1"/>
           <p:nvPr/>
         </p:nvSpPr>
@@ -7439,7 +7664,7 @@
       </p:sp>
       <p:sp>
         <p:nvSpPr>
-          <p:cNvPr id="4" name="TextBox 3"/>
+          <p:cNvPr id="5" name="TextBox 4"/>
           <p:cNvSpPr txBox="1"/>
           <p:nvPr/>
         </p:nvSpPr>
@@ -7476,7 +7701,7 @@
             <a:r>
               <a:rPr sz="4000" b="1">
                 <a:solidFill>
-                  <a:srgbClr val="22D3EE"/>
+                  <a:srgbClr val="FF734C"/>
                 </a:solidFill>
                 <a:latin typeface="Sora"/>
               </a:rPr>
@@ -7487,7 +7712,7 @@
       </p:sp>
       <p:sp>
         <p:nvSpPr>
-          <p:cNvPr id="5" name="TextBox 4"/>
+          <p:cNvPr id="6" name="TextBox 5"/>
           <p:cNvSpPr txBox="1"/>
           <p:nvPr/>
         </p:nvSpPr>
@@ -7515,7 +7740,7 @@
             <a:r>
               <a:rPr sz="1800" b="1">
                 <a:solidFill>
-                  <a:srgbClr val="22D3EE"/>
+                  <a:srgbClr val="FF734C"/>
                 </a:solidFill>
                 <a:latin typeface="Sora"/>
               </a:rPr>
@@ -7552,7 +7777,7 @@
             <a:r>
               <a:rPr sz="1800" b="1">
                 <a:solidFill>
-                  <a:srgbClr val="22D3EE"/>
+                  <a:srgbClr val="FF734C"/>
                 </a:solidFill>
                 <a:latin typeface="Sora"/>
               </a:rPr>
@@ -7589,7 +7814,7 @@
             <a:r>
               <a:rPr sz="1800" b="1">
                 <a:solidFill>
-                  <a:srgbClr val="22D3EE"/>
+                  <a:srgbClr val="FF734C"/>
                 </a:solidFill>
                 <a:latin typeface="Sora"/>
               </a:rPr>
@@ -7618,7 +7843,7 @@
       </p:sp>
       <p:sp>
         <p:nvSpPr>
-          <p:cNvPr id="6" name="TextBox 5"/>
+          <p:cNvPr id="7" name="TextBox 6"/>
           <p:cNvSpPr txBox="1"/>
           <p:nvPr/>
         </p:nvSpPr>
@@ -7657,7 +7882,7 @@
       </p:sp>
       <p:sp>
         <p:nvSpPr>
-          <p:cNvPr id="7" name="TextBox 6"/>
+          <p:cNvPr id="8" name="TextBox 7"/>
           <p:cNvSpPr txBox="1"/>
           <p:nvPr/>
         </p:nvSpPr>
@@ -7741,7 +7966,7 @@
           </a:solidFill>
           <a:ln w="25400">
             <a:solidFill>
-              <a:srgbClr val="22D3EE"/>
+              <a:srgbClr val="DD2023"/>
             </a:solidFill>
           </a:ln>
         </p:spPr>
@@ -7767,9 +7992,33 @@
           </a:p>
         </p:txBody>
       </p:sp>
-      <p:sp>
-        <p:nvSpPr>
-          <p:cNvPr id="3" name="TextBox 2"/>
+      <p:pic>
+        <p:nvPicPr>
+          <p:cNvPr id="3" name="Picture 2" descr="nextrare-logo.png"/>
+          <p:cNvPicPr>
+            <a:picLocks noChangeAspect="1"/>
+          </p:cNvPicPr>
+          <p:nvPr/>
+        </p:nvPicPr>
+        <p:blipFill>
+          <a:blip r:embed="rId2"/>
+          <a:stretch>
+            <a:fillRect/>
+          </a:stretch>
+        </p:blipFill>
+        <p:spPr>
+          <a:xfrm>
+            <a:off x="9418320" y="804672"/>
+            <a:ext cx="1728216" cy="329184"/>
+          </a:xfrm>
+          <a:prstGeom prst="rect">
+            <a:avLst/>
+          </a:prstGeom>
+        </p:spPr>
+      </p:pic>
+      <p:sp>
+        <p:nvSpPr>
+          <p:cNvPr id="4" name="TextBox 3"/>
           <p:cNvSpPr txBox="1"/>
           <p:nvPr/>
         </p:nvSpPr>
@@ -7808,7 +8057,7 @@
       </p:sp>
       <p:sp>
         <p:nvSpPr>
-          <p:cNvPr id="4" name="TextBox 3"/>
+          <p:cNvPr id="5" name="TextBox 4"/>
           <p:cNvSpPr txBox="1"/>
           <p:nvPr/>
         </p:nvSpPr>
@@ -7845,7 +8094,7 @@
             <a:r>
               <a:rPr sz="4000" b="1">
                 <a:solidFill>
-                  <a:srgbClr val="22D3EE"/>
+                  <a:srgbClr val="FF734C"/>
                 </a:solidFill>
                 <a:latin typeface="Sora"/>
               </a:rPr>
@@ -7856,7 +8105,7 @@
       </p:sp>
       <p:sp>
         <p:nvSpPr>
-          <p:cNvPr id="5" name="TextBox 4"/>
+          <p:cNvPr id="6" name="TextBox 5"/>
           <p:cNvSpPr txBox="1"/>
           <p:nvPr/>
         </p:nvSpPr>
@@ -8024,7 +8273,7 @@
       </p:sp>
       <p:sp>
         <p:nvSpPr>
-          <p:cNvPr id="6" name="TextBox 5"/>
+          <p:cNvPr id="7" name="TextBox 6"/>
           <p:cNvSpPr txBox="1"/>
           <p:nvPr/>
         </p:nvSpPr>
@@ -8063,7 +8312,7 @@
       </p:sp>
       <p:sp>
         <p:nvSpPr>
-          <p:cNvPr id="7" name="TextBox 6"/>
+          <p:cNvPr id="8" name="TextBox 7"/>
           <p:cNvSpPr txBox="1"/>
           <p:nvPr/>
         </p:nvSpPr>

</xml_diff>